<commit_message>
Presentation: re-run results, control run and current app
- Result 1 chart and text: first setup (transformer 0.692, word model 0.775)
  against both models tuned on held-out contracts (0.797, 0.785; ensemble 0.809)
- Problems slide: the model read only half of each window
- Training, pipeline and testing slides: 512 tokens, 81 validation contracts,
  control run that changes only the window length
- App slide: new screenshot, 90% of High-risk clauses found by default,
  about a minute per contract, 42 tests; conclusion updated to match
- Speaker notes updated on the same slides

Co-Authored-By: Claude Opus 5.5 <noreply@anthropic.com>
</commit_message>
<xml_diff>
--- a/P25301051-p3-presentation-15-slides.pptx
+++ b/P25301051-p3-presentation-15-slides.pptx
@@ -469,19 +469,19 @@
               <c:strCache>
                 <c:ptCount val="5"/>
                 <c:pt idx="0">
-                  <c:v>Either one (OR)</c:v>
+                  <c:v>Transformer (first)</c:v>
                 </c:pt>
                 <c:pt idx="1">
-                  <c:v>Transformer alone</c:v>
+                  <c:v>Word model (first)</c:v>
                 </c:pt>
                 <c:pt idx="2">
-                  <c:v>Average of both</c:v>
+                  <c:v>Word model (tuned)</c:v>
                 </c:pt>
                 <c:pt idx="3">
-                  <c:v>Word model (TF-IDF)</c:v>
+                  <c:v>Transformer (tuned)</c:v>
                 </c:pt>
                 <c:pt idx="4">
-                  <c:v>Both agree (AND)</c:v>
+                  <c:v>Both agree (tuned)</c:v>
                 </c:pt>
               </c:strCache>
             </c:strRef>
@@ -499,13 +499,13 @@
                   <c:v>0</c:v>
                 </c:pt>
                 <c:pt idx="2">
-                  <c:v>0.718</c:v>
+                  <c:v>0</c:v>
                 </c:pt>
                 <c:pt idx="3">
                   <c:v>0</c:v>
                 </c:pt>
                 <c:pt idx="4">
-                  <c:v>0.779</c:v>
+                  <c:v>0.809</c:v>
                 </c:pt>
               </c:numCache>
             </c:numRef>
@@ -539,19 +539,19 @@
               <c:strCache>
                 <c:ptCount val="5"/>
                 <c:pt idx="0">
-                  <c:v>Either one (OR)</c:v>
+                  <c:v>Transformer (first)</c:v>
                 </c:pt>
                 <c:pt idx="1">
-                  <c:v>Transformer alone</c:v>
+                  <c:v>Word model (first)</c:v>
                 </c:pt>
                 <c:pt idx="2">
-                  <c:v>Average of both</c:v>
+                  <c:v>Word model (tuned)</c:v>
                 </c:pt>
                 <c:pt idx="3">
-                  <c:v>Word model (TF-IDF)</c:v>
+                  <c:v>Transformer (tuned)</c:v>
                 </c:pt>
                 <c:pt idx="4">
-                  <c:v>Both agree (AND)</c:v>
+                  <c:v>Both agree (tuned)</c:v>
                 </c:pt>
               </c:strCache>
             </c:strRef>
@@ -566,13 +566,13 @@
                   <c:v>0</c:v>
                 </c:pt>
                 <c:pt idx="1">
-                  <c:v>0</c:v>
+                  <c:v>0.775</c:v>
                 </c:pt>
                 <c:pt idx="2">
-                  <c:v>0</c:v>
+                  <c:v>0.785</c:v>
                 </c:pt>
                 <c:pt idx="3">
-                  <c:v>0.775</c:v>
+                  <c:v>0</c:v>
                 </c:pt>
                 <c:pt idx="4">
                   <c:v>0</c:v>
@@ -609,19 +609,19 @@
               <c:strCache>
                 <c:ptCount val="5"/>
                 <c:pt idx="0">
-                  <c:v>Either one (OR)</c:v>
+                  <c:v>Transformer (first)</c:v>
                 </c:pt>
                 <c:pt idx="1">
-                  <c:v>Transformer alone</c:v>
+                  <c:v>Word model (first)</c:v>
                 </c:pt>
                 <c:pt idx="2">
-                  <c:v>Average of both</c:v>
+                  <c:v>Word model (tuned)</c:v>
                 </c:pt>
                 <c:pt idx="3">
-                  <c:v>Word model (TF-IDF)</c:v>
+                  <c:v>Transformer (tuned)</c:v>
                 </c:pt>
                 <c:pt idx="4">
-                  <c:v>Both agree (AND)</c:v>
+                  <c:v>Both agree (tuned)</c:v>
                 </c:pt>
               </c:strCache>
             </c:strRef>
@@ -636,13 +636,13 @@
                   <c:v>0.692</c:v>
                 </c:pt>
                 <c:pt idx="1">
-                  <c:v>0.692</c:v>
+                  <c:v>0</c:v>
                 </c:pt>
                 <c:pt idx="2">
                   <c:v>0</c:v>
                 </c:pt>
                 <c:pt idx="3">
-                  <c:v>0</c:v>
+                  <c:v>0.797</c:v>
                 </c:pt>
                 <c:pt idx="4">
                   <c:v>0</c:v>
@@ -1347,7 +1347,7 @@
           <a:lstStyle/>
           <a:p>
             <a:r>
-              <a:t>We kept 102 contracts completely aside for testing. To see how sure each score is, we re-ran the test 10,000 times on random mixes of these contracts. Nothing was chosen by looking at the test results.</a:t>
+              <a:t>We kept 102 contracts completely aside for testing, and 81 of the training contracts aside to choose settings. To see how sure each score is, we re-ran the test 10,000 times on random mixes of these contracts. Nothing was chosen by looking at the test results.</a:t>
             </a:r>
           </a:p>
         </p:txBody>
@@ -1605,7 +1605,7 @@
           <a:lstStyle/>
           <a:p>
             <a:r>
-              <a:t>These were practical problems, and each one had a clear fix. Before choosing windows we also checked a 'search first' design; it could reach at most 64% of clauses, so we did not use it.</a:t>
+              <a:t>These were practical problems, and each one had a clear fix. The most important one we found late: our first clause model read only about half of each window, so many of its training examples pointed at text it never saw. Fixing that is what made the transformer competitive. Before choosing windows we also checked a 'search first' design; it could reach at most 64% of clauses, so we did not use it.</a:t>
             </a:r>
           </a:p>
         </p:txBody>
@@ -1691,7 +1691,7 @@
           <a:lstStyle/>
           <a:p>
             <a:r>
-              <a:t>Clausify runs all our models on any contract you paste or upload. It shows the risky clauses first, with a reason and a simple explanation. It says clearly on screen that it is not legal advice.</a:t>
+              <a:t>Clausify runs all our models on any contract you paste or upload. It shows the risky clauses first, with a reason and a simple explanation. By default it uses the setting that finds 90% of High-risk clauses on the test set. It says clearly on screen that it is not legal advice.</a:t>
             </a:r>
           </a:p>
         </p:txBody>
@@ -2035,7 +2035,7 @@
           <a:lstStyle/>
           <a:p>
             <a:r>
-              <a:t>The model reads every window and keeps the highest score for the whole contract. A simple word model reads the whole contract too, and a clause is reported only when both agree. Then the text model finds the words, the risk table adds the level, and FLAN-T5 adds one simple sentence.</a:t>
+              <a:t>The model reads every window and keeps the highest score for the whole contract. A simple word model reads the whole contract too. Each model gets a threshold for each clause type, chosen on contracts we kept aside. Then the text model finds the words, the risk table adds the level, and FLAN-T5 adds one simple sentence.</a:t>
             </a:r>
           </a:p>
         </p:txBody>
@@ -2121,7 +2121,7 @@
           <a:lstStyle/>
           <a:p>
             <a:r>
-              <a:t>All three models learned only from the 408 training contracts. We built the simple word-count model first, so the AI models had a fair score to beat.</a:t>
+              <a:t>All three models learned only from the 408 training contracts, and for the clause finder we kept 81 of them aside to choose its settings. We built the simple word-count model first, so the AI models had a fair score to beat. The final clause finder reads all 512 tokens of each window; the first one read only 256.</a:t>
             </a:r>
           </a:p>
         </p:txBody>
@@ -2207,7 +2207,7 @@
           <a:lstStyle/>
           <a:p>
             <a:r>
-              <a:t>When both models must agree, the F1 score is 0.779, the best of all. The simple word model is very close at 0.775, so we call these two a tie. The clear result is that the simple word model beats the transformer alone, and this held in every check.</a:t>
+              <a:t>Our first transformer lost to the simple word model, 0.692 to 0.775. We then found it was reading only half of each window. With the whole window read and both models tuned on contracts kept aside, the two tie, 0.797 to 0.785, and when both must agree the F1 is 0.809, a lead the bootstrap confirms. A second run that changed only the window length shows that reading the whole window is worth 0.036 on its own.</a:t>
             </a:r>
           </a:p>
         </p:txBody>
@@ -2379,7 +2379,7 @@
           <a:lstStyle/>
           <a:p>
             <a:r>
-              <a:t>We found each of these by testing the app with real inputs, then fixed it and tested again. 38 automatic tests now check these cases every time.</a:t>
+              <a:t>We found each of these by testing the app with real inputs, then fixed it and tested again. 42 automatic tests now check these cases every time.</a:t>
             </a:r>
           </a:p>
         </p:txBody>
@@ -3856,7 +3856,7 @@
                 <a:ea typeface="Calibri" pitchFamily="34" charset="-122"/>
                 <a:cs typeface="Calibri" pitchFamily="34" charset="-120"/>
               </a:rPr>
-              <a:t>The app reads at most 30 windows (about 45,500 characters), so even the longest test contract takes only 34.8 seconds. The app tells the user this.</a:t>
+              <a:t>The app reads at most 30 windows (about 45,500 characters), so even the longest test contract takes under two minutes. The app tells the user this.</a:t>
             </a:r>
             <a:endParaRPr lang="en-US" sz="1550" dirty="0"/>
           </a:p>
@@ -4196,7 +4196,7 @@
                 <a:ea typeface="Calibri" pitchFamily="34" charset="-122"/>
                 <a:cs typeface="Calibri" pitchFamily="34" charset="-120"/>
               </a:rPr>
-              <a:t>102 test contracts kept aside  (408 used for training)</a:t>
+              <a:t>102 test contracts kept aside  (408 for training, 81 of them to choose settings)</a:t>
             </a:r>
             <a:endParaRPr lang="en-US" sz="1700" dirty="0"/>
           </a:p>
@@ -4435,7 +4435,7 @@
                 <a:ea typeface="Calibri" pitchFamily="34" charset="-122"/>
                 <a:cs typeface="Calibri" pitchFamily="34" charset="-120"/>
               </a:rPr>
-              <a:t>We report accuracy and the F1 score (a balance of finding clauses and avoiding false alarms), a word-overlap score for clause text, and ROUGE-L for explanations. We re-checked the main result with 3 random seeds, all the training data and 20 different splits.</a:t>
+              <a:t>We report accuracy and the F1 score (a balance of finding clauses and avoiding false alarms), a word-overlap score for clause text, and ROUGE-L for explanations. We re-checked the main result with 3 random seeds, all the training data, 20 different splits and a run that changes only the window length.</a:t>
             </a:r>
             <a:endParaRPr lang="en-US" sz="1500" dirty="0"/>
           </a:p>
@@ -4604,7 +4604,7 @@
                 <a:ea typeface="Calibri" pitchFamily="34" charset="-122"/>
                 <a:cs typeface="Calibri" pitchFamily="34" charset="-120"/>
               </a:rPr>
-              <a:t>F1 score (0 to 1, higher is better) on 4,182 test checks</a:t>
+              <a:t>F1 on 4,182 test checks: first setup, then both models tuned on held-out contracts</a:t>
             </a:r>
             <a:endParaRPr lang="en-US" sz="1700" dirty="0"/>
           </a:p>
@@ -4660,7 +4660,7 @@
                 <a:ea typeface="Calibri" pitchFamily="34" charset="-122"/>
                 <a:cs typeface="Calibri" pitchFamily="34" charset="-120"/>
               </a:rPr>
-              <a:t>clause types (Fig. 5.3)</a:t>
+              <a:t>clause types, first setup (Fig. 5.3)</a:t>
             </a:r>
             <a:endParaRPr lang="en-US" sz="1500" dirty="0"/>
           </a:p>
@@ -4790,7 +4790,7 @@
                 <a:ea typeface="Calibri" pitchFamily="34" charset="-122"/>
                 <a:cs typeface="Calibri" pitchFamily="34" charset="-120"/>
               </a:rPr>
-              <a:t>F1 0.779 and accuracy 85.65%. It finds 78.41% of real clauses, and 77.38% of what it reports is correct. It is almost tied with the word model.</a:t>
+              <a:t>F1 0.809 and accuracy 88.43%, with every setting chosen on contracts kept aside. It beats the tuned word model (0.785) by more than the error margin.</a:t>
             </a:r>
             <a:endParaRPr lang="en-US" sz="1550" dirty="0"/>
           </a:p>
@@ -4881,7 +4881,7 @@
                 <a:ea typeface="Calibri" pitchFamily="34" charset="-122"/>
                 <a:cs typeface="Calibri" pitchFamily="34" charset="-120"/>
               </a:rPr>
-              <a:t>The simple word model is strong</a:t>
+              <a:t>Reading the whole window mattered</a:t>
             </a:r>
             <a:endParaRPr lang="en-US" sz="1650" dirty="0"/>
           </a:p>
@@ -4920,7 +4920,7 @@
                 <a:ea typeface="Calibri" pitchFamily="34" charset="-122"/>
                 <a:cs typeface="Calibri" pitchFamily="34" charset="-120"/>
               </a:rPr>
-              <a:t>TF-IDF scores 0.775 and beats the transformer alone (0.692). This held with 3 random seeds, all the training data and 6 ways of combining scores.</a:t>
+              <a:t>Our first model read half of each window and lost (0.692 vs 0.775). Reading all of it and tuning both fairly: 0.797 vs 0.785, a tie.</a:t>
             </a:r>
             <a:endParaRPr lang="en-US" sz="1550" dirty="0"/>
           </a:p>
@@ -6573,7 +6573,7 @@
                 <a:ea typeface="Calibri" pitchFamily="34" charset="-122"/>
                 <a:cs typeface="Calibri" pitchFamily="34" charset="-120"/>
               </a:rPr>
-              <a:t>About 30 seconds for a normal contract; 34.8 s at most.</a:t>
+              <a:t>About a minute for a normal contract; 103 s at most.</a:t>
             </a:r>
             <a:endParaRPr lang="en-US" sz="1550" dirty="0"/>
           </a:p>
@@ -6703,7 +6703,7 @@
                 <a:ea typeface="Calibri" pitchFamily="34" charset="-122"/>
                 <a:cs typeface="Calibri" pitchFamily="34" charset="-120"/>
               </a:rPr>
-              <a:t>By default it finds 84% of High-risk clauses.</a:t>
+              <a:t>By default it finds 90% of High-risk clauses.</a:t>
             </a:r>
             <a:endParaRPr lang="en-US" sz="1550" dirty="0"/>
           </a:p>
@@ -7522,7 +7522,7 @@
                 <a:ea typeface="Calibri" pitchFamily="34" charset="-122"/>
                 <a:cs typeface="Calibri" pitchFamily="34" charset="-120"/>
               </a:rPr>
-              <a:t>PDF and CSV files; all 38 app tests pass</a:t>
+              <a:t>PDF and CSV files; all 42 app tests pass</a:t>
             </a:r>
             <a:endParaRPr lang="en-US" sz="1450" dirty="0"/>
           </a:p>
@@ -7964,7 +7964,7 @@
                 <a:ea typeface="Calibri" pitchFamily="34" charset="-122"/>
                 <a:cs typeface="Calibri" pitchFamily="34" charset="-120"/>
               </a:rPr>
-              <a:t>F1 0.779 and accuracy 85.65% on 102 unseen contracts</a:t>
+              <a:t>F1 0.809 and accuracy 88.43%; finds 90% of High-risk clauses</a:t>
             </a:r>
             <a:endParaRPr lang="en-US" sz="1500" dirty="0"/>
           </a:p>
@@ -8174,7 +8174,7 @@
                 <a:ea typeface="Calibri" pitchFamily="34" charset="-122"/>
                 <a:cs typeface="Calibri" pitchFamily="34" charset="-120"/>
               </a:rPr>
-              <a:t>Clausify takes about 30 s per contract; all 38 tests pass</a:t>
+              <a:t>Clausify takes about a minute per contract; all 42 tests pass</a:t>
             </a:r>
             <a:endParaRPr lang="en-US" sz="1500" dirty="0"/>
           </a:p>
@@ -14017,7 +14017,7 @@
                 <a:ea typeface="Calibri" pitchFamily="34" charset="-122"/>
                 <a:cs typeface="Calibri" pitchFamily="34" charset="-120"/>
               </a:rPr>
-              <a:t>Both models must agree</a:t>
+              <a:t>Settings chosen fairly</a:t>
             </a:r>
             <a:endParaRPr lang="en-US" sz="1650" dirty="0"/>
           </a:p>
@@ -14056,7 +14056,7 @@
                 <a:ea typeface="Calibri" pitchFamily="34" charset="-122"/>
                 <a:cs typeface="Calibri" pitchFamily="34" charset="-120"/>
               </a:rPr>
-              <a:t>A clause is reported only when both models give it a score of at least 0.5. This cuts false alarms.</a:t>
+              <a:t>Each model's threshold for each clause type was chosen on 81 training contracts kept aside, never on the test set.</a:t>
             </a:r>
             <a:endParaRPr lang="en-US" sz="1550" dirty="0"/>
           </a:p>
@@ -15047,7 +15047,7 @@
                 <a:ea typeface="Calibri" pitchFamily="34" charset="-122"/>
                 <a:cs typeface="Calibri" pitchFamily="34" charset="-120"/>
               </a:rPr>
-              <a:t>DistilBERT · 24,000 windows</a:t>
+              <a:t>DistilBERT · 24,000 windows · 512 tokens</a:t>
             </a:r>
             <a:endParaRPr lang="en-US" sz="1450" dirty="0"/>
           </a:p>
@@ -15086,7 +15086,7 @@
                 <a:ea typeface="Cambria" pitchFamily="34" charset="-122"/>
                 <a:cs typeface="Cambria" pitchFamily="34" charset="-120"/>
               </a:rPr>
-              <a:t>≈50 min</a:t>
+              <a:t>≈3 h</a:t>
             </a:r>
             <a:endParaRPr lang="en-US" sz="1550" dirty="0"/>
           </a:p>
@@ -15522,7 +15522,7 @@
                 <a:ea typeface="Calibri" pitchFamily="34" charset="-122"/>
                 <a:cs typeface="Calibri" pitchFamily="34" charset="-120"/>
               </a:rPr>
-              <a:t>Apple M4 laptop with 16 GB memory and no NVIDIA GPU. Each model saw its data twice. Training again in October gave the same scores (within 0.003).</a:t>
+              <a:t>Apple M4 laptop with 16 GB memory and no NVIDIA GPU. The clause finder reads all 512 tokens of each window, and we kept the best of three passes over the data.</a:t>
             </a:r>
             <a:endParaRPr lang="en-US" sz="1500" dirty="0"/>
           </a:p>
@@ -15652,7 +15652,7 @@
                 <a:ea typeface="Calibri" pitchFamily="34" charset="-122"/>
                 <a:cs typeface="Calibri" pitchFamily="34" charset="-120"/>
               </a:rPr>
-              <a:t>A word-count model (TF-IDF) with one classifier for each clause type. It trains in under a minute and scores 0.775.</a:t>
+              <a:t>A word-count model (TF-IDF) with one classifier for each clause type. It trains in under a minute and scores 0.775, or 0.785 once tuned.</a:t>
             </a:r>
             <a:endParaRPr lang="en-US" sz="1550" dirty="0"/>
           </a:p>
@@ -15782,7 +15782,7 @@
                 <a:ea typeface="Calibri" pitchFamily="34" charset="-122"/>
                 <a:cs typeface="Calibri" pitchFamily="34" charset="-120"/>
               </a:rPr>
-              <a:t>The training loss fell from 0.57 to 0.26, and the held-back check stayed close (0.275 to 0.254), so the model did not just memorise.</a:t>
+              <a:t>The held-back loss was lowest after the second of three passes (0.245), so we kept that pass and the model did not just memorise.</a:t>
             </a:r>
             <a:endParaRPr lang="en-US" sz="1550" dirty="0"/>
           </a:p>
@@ -15912,7 +15912,7 @@
                 <a:ea typeface="Calibri" pitchFamily="34" charset="-122"/>
                 <a:cs typeface="Calibri" pitchFamily="34" charset="-120"/>
               </a:rPr>
-              <a:t>We used standard settings and chose nothing by looking at the test contracts. 5% of the training windows were kept back for checking.</a:t>
+              <a:t>We kept 81 training contracts aside and chose every setting on them. The 102 test contracts were scored once, at the end.</a:t>
             </a:r>
             <a:endParaRPr lang="en-US" sz="1550" dirty="0"/>
           </a:p>
@@ -16432,7 +16432,7 @@
                 <a:ea typeface="Calibri" pitchFamily="34" charset="-122"/>
                 <a:cs typeface="Calibri" pitchFamily="34" charset="-120"/>
               </a:rPr>
-              <a:t>Memory was not freed between runs</a:t>
+              <a:t>The model read only half of each window</a:t>
             </a:r>
             <a:endParaRPr lang="en-US" sz="1650" dirty="0"/>
           </a:p>
@@ -16471,7 +16471,7 @@
                 <a:ea typeface="Calibri" pitchFamily="34" charset="-122"/>
                 <a:cs typeface="Calibri" pitchFamily="34" charset="-120"/>
               </a:rPr>
-              <a:t>We trained one model at a time and trained the small explanation model on the CPU.</a:t>
+              <a:t>At 256 tokens it saw about 1,000 of 2,000 characters, and 23% of its examples were about text it never read. 512 tokens fixed this.</a:t>
             </a:r>
             <a:endParaRPr lang="en-US" sz="1550" dirty="0"/>
           </a:p>

</xml_diff>

<commit_message>
Presentation: clause-mode figures, test count, next steps
Slide 10 shows the re-run clause-mode accuracy, slides 14-15 the 43 app tests,
and the next steps no longer list the risk-table review or calibration (done).

Co-Authored-By: Claude Opus 5.5 <noreply@anthropic.com>
</commit_message>
<xml_diff>
--- a/P25301051-p3-presentation-15-slides.pptx
+++ b/P25301051-p3-presentation-15-slides.pptx
@@ -1433,7 +1433,7 @@
           <a:lstStyle/>
           <a:p>
             <a:r>
-              <a:t>We built a complete system that works on contracts it has never seen, and a working app. Next, we want a lawyer to check the risk table, make the confidence bar match real chances, test the app with real users, write explanations for each clause, and try contracts from outside CUAD, such as from Bangladesh.</a:t>
+              <a:t>We built a complete system that works on contracts it has never seen, and a working app. Next, we want to judge each clause's own wording, train the text model to say when a window holds no clause, test the app with real users, write explanations for each clause, and try contracts from outside CUAD, such as from Bangladesh.</a:t>
             </a:r>
           </a:p>
         </p:txBody>
@@ -2293,7 +2293,7 @@
           <a:lstStyle/>
           <a:p>
             <a:r>
-              <a:t>Each clause type gets one risk level, decided by five simple questions. 8 types are High, 22 are Medium and 11 are Low. A lawyer has not checked the table yet; that is our first next step.</a:t>
+              <a:t>Each clause type gets one risk level, decided by five simple questions. 8 types are High, 22 are Medium and 11 are Low.</a:t>
             </a:r>
           </a:p>
         </p:txBody>
@@ -2379,7 +2379,7 @@
           <a:lstStyle/>
           <a:p>
             <a:r>
-              <a:t>We found each of these by testing the app with real inputs, then fixed it and tested again. 42 automatic tests now check these cases every time.</a:t>
+              <a:t>We found each of these by testing the app with real inputs, then fixed it and tested again. 43 automatic tests now check these cases every time.</a:t>
             </a:r>
           </a:p>
         </p:txBody>
@@ -3596,7 +3596,7 @@
                 <a:ea typeface="Calibri" pitchFamily="34" charset="-122"/>
                 <a:cs typeface="Calibri" pitchFamily="34" charset="-120"/>
               </a:rPr>
-              <a:t>“Parties” scored about 0.98 on almost any text. We adjusted each score using 1,586 training clauses, and correct answers rose from 9.6% to 42.3%.</a:t>
+              <a:t>“Parties” scored about 0.98 on almost any text. We adjusted each score using 1,586 training clauses, and correct answers rose from 5.1% to 44.9%.</a:t>
             </a:r>
             <a:endParaRPr lang="en-US" sz="1550" dirty="0"/>
           </a:p>
@@ -7522,7 +7522,7 @@
                 <a:ea typeface="Calibri" pitchFamily="34" charset="-122"/>
                 <a:cs typeface="Calibri" pitchFamily="34" charset="-120"/>
               </a:rPr>
-              <a:t>PDF and CSV files; all 42 app tests pass</a:t>
+              <a:t>PDF and CSV files; all 43 app tests pass</a:t>
             </a:r>
             <a:endParaRPr lang="en-US" sz="1450" dirty="0"/>
           </a:p>
@@ -8174,7 +8174,7 @@
                 <a:ea typeface="Calibri" pitchFamily="34" charset="-122"/>
                 <a:cs typeface="Calibri" pitchFamily="34" charset="-120"/>
               </a:rPr>
-              <a:t>Clausify takes about a minute per contract; all 42 tests pass</a:t>
+              <a:t>Clausify takes about a minute per contract; all 43 tests pass</a:t>
             </a:r>
             <a:endParaRPr lang="en-US" sz="1500" dirty="0"/>
           </a:p>
@@ -8279,7 +8279,7 @@
                 <a:ea typeface="Calibri" pitchFamily="34" charset="-122"/>
                 <a:cs typeface="Calibri" pitchFamily="34" charset="-120"/>
               </a:rPr>
-              <a:t>A lawyer checks the risk table</a:t>
+              <a:t>Judge each clause, not just its type</a:t>
             </a:r>
             <a:endParaRPr lang="en-US" sz="1600" dirty="0"/>
           </a:p>
@@ -8318,7 +8318,7 @@
                 <a:ea typeface="Calibri" pitchFamily="34" charset="-122"/>
                 <a:cs typeface="Calibri" pitchFamily="34" charset="-120"/>
               </a:rPr>
-              <a:t>two or three lawyers, and we measure how much they agree</a:t>
+              <a:t>read the actual amount, limit or period in the clause</a:t>
             </a:r>
             <a:endParaRPr lang="en-US" sz="1500" dirty="0"/>
           </a:p>
@@ -8384,7 +8384,7 @@
                 <a:ea typeface="Calibri" pitchFamily="34" charset="-122"/>
                 <a:cs typeface="Calibri" pitchFamily="34" charset="-120"/>
               </a:rPr>
-              <a:t>Make the confidence bar honest</a:t>
+              <a:t>Let the text model say “not here”</a:t>
             </a:r>
             <a:endParaRPr lang="en-US" sz="1600" dirty="0"/>
           </a:p>
@@ -8423,7 +8423,7 @@
                 <a:ea typeface="Calibri" pitchFamily="34" charset="-122"/>
                 <a:cs typeface="Calibri" pitchFamily="34" charset="-120"/>
               </a:rPr>
-              <a:t>so a score of 0.9 really means a 90% chance</a:t>
+              <a:t>the main loss is now the text model, not the window</a:t>
             </a:r>
             <a:endParaRPr lang="en-US" sz="1500" dirty="0"/>
           </a:p>

</xml_diff>

<commit_message>
Presentation and report cross-matched
Slides:
- Slide 11 says which checks were run on which setup
- Slide 12: the app's setting finds 49 of the 70 rare clauses
- Slide 13: whole-system result (22.1%) and the second-half-of-window finding
- Slide 14: calibrated chance on the cards, new screenshot
- Speaker notes on slides 13 and 14 updated

Report:
- App screenshots (Figures 4.15 and the clause cards) retaken with the
  calibrated chance; clause-card description updated

Every number on the slides, notes and charts appears in the report.

Co-Authored-By: Claude Opus 5.5 <noreply@anthropic.com>
</commit_message>
<xml_diff>
--- a/P25301051-p3-presentation-15-slides.pptx
+++ b/P25301051-p3-presentation-15-slides.pptx
@@ -1261,7 +1261,7 @@
           <a:lstStyle/>
           <a:p>
             <a:r>
-              <a:t>For example, for a clause that blocks transferring the contract, the app shows: 'You cannot transfer this contract to someone else without permission.' The model picks the right sentence 70% of the time.</a:t>
+              <a:t>For example, for a clause that blocks transferring the contract, the app shows: 'You cannot transfer this contract to someone else without permission.' The model picks the right sentence 70% of the time. Over the whole system, 22.1% of real clauses get a good quote. The clause finder now picks the right window 82.6% of the time, so the main loss is the text model, which almost never extracts a clause from the second half of a window.</a:t>
             </a:r>
           </a:p>
         </p:txBody>
@@ -1691,7 +1691,7 @@
           <a:lstStyle/>
           <a:p>
             <a:r>
-              <a:t>Clausify runs all our models on any contract you paste or upload. It shows the risky clauses first, with a reason and a simple explanation. By default it uses the setting that finds 90% of High-risk clauses on the test set. It says clearly on screen that it is not legal advice.</a:t>
+              <a:t>Clausify runs all our models on any contract you paste or upload. It shows the risky clauses first, with a reason and a simple explanation. By default it uses the setting that finds 90% of High-risk clauses on the test set. Each card shows a calibrated chance, fitted on contracts we kept aside, so 80% means about 80%. It says clearly on screen that it is not legal advice.</a:t>
             </a:r>
           </a:p>
         </p:txBody>
@@ -4435,7 +4435,7 @@
                 <a:ea typeface="Calibri" pitchFamily="34" charset="-122"/>
                 <a:cs typeface="Calibri" pitchFamily="34" charset="-120"/>
               </a:rPr>
-              <a:t>We report accuracy and the F1 score (a balance of finding clauses and avoiding false alarms), a word-overlap score for clause text, and ROUGE-L for explanations. We re-checked the main result with 3 random seeds, all the training data, 20 different splits and a run that changes only the window length.</a:t>
+              <a:t>We report accuracy and the F1 score (a balance of finding clauses and avoiding false alarms), a word-overlap score for clause text, and ROUGE-L for explanations. We checked the first setup with 3 random seeds, all the training data and 20 different splits, and the final one with a run that changes only the window length.</a:t>
             </a:r>
             <a:endParaRPr lang="en-US" sz="1500" dirty="0"/>
           </a:p>
@@ -5050,7 +5050,7 @@
                 <a:ea typeface="Calibri" pitchFamily="34" charset="-122"/>
                 <a:cs typeface="Calibri" pitchFamily="34" charset="-120"/>
               </a:rPr>
-              <a:t>Document Name 1.000, Parties 0.995, Agreement Date 0.963, Governing Law 0.931. The rarest types have only 2 to 7 test examples, too few to learn.</a:t>
+              <a:t>Document Name 1.000, Parties 0.995, Agreement Date 0.963, Governing Law 0.931. The rarest types have only 2 to 7 test examples; the app's setting still finds 49 of the 70 rare clauses.</a:t>
             </a:r>
             <a:endParaRPr lang="en-US" sz="1550" dirty="0"/>
           </a:p>
@@ -6235,7 +6235,7 @@
                 <a:ea typeface="Calibri" pitchFamily="34" charset="-122"/>
                 <a:cs typeface="Calibri" pitchFamily="34" charset="-120"/>
               </a:rPr>
-              <a:t>The text score is measured when the model is given the right part of the contract, and our model is about ten times smaller than the best published one. The explanation describes the clause type, not each clause's details, so it scores only 0.116 against clause-specific references.</a:t>
+              <a:t>Given the right part of the contract, the text model scores 0.764. Over the whole system only 22.1% of clauses get a good quote: the right window is found 82.6% of the time, but clauses in a window's second half are rarely extracted. The explanation describes the clause type, so it scores 0.116 against clause-specific references.</a:t>
             </a:r>
             <a:endParaRPr lang="en-US" sz="1550" dirty="0"/>
           </a:p>
@@ -7262,7 +7262,7 @@
                 <a:ea typeface="Calibri" pitchFamily="34" charset="-122"/>
                 <a:cs typeface="Calibri" pitchFamily="34" charset="-120"/>
               </a:rPr>
-              <a:t>clause type, risk level and reason, a simple-English line and the quoted text</a:t>
+              <a:t>clause type, risk level and reason, a calibrated chance, a simple-English line and the quoted text</a:t>
             </a:r>
             <a:endParaRPr lang="en-US" sz="1450" dirty="0"/>
           </a:p>

</xml_diff>

<commit_message>
Fix list (35 items): front matter, cross-references, consistency
Done: supervisor title (Lecturer); dates Spring 2027 / January 2027;
duplicate and self-referencing section citations; usability pointer to
6.4; ethics paragraph and speed requirement updated; first-setup tuning
statements labelled and Table 4.4 extended; Figure 4.12 redrawn for the
app; final confusion counts; readability wording; explainable-AI
citation (Atkinson et al. 2020); 9.7%/11.4% given for whole contracts vs
the app; RQ counts and "quick" check wording aligned; five models named;
46 app checks; three bibliography entries; READMEs, usability protocol,
notebook README, viva counts and slides 2/14; American spelling
throughout; stage numbering explained (paper drops numbers); "Brac
University" everywhere. Left as is by choice: items 3 and 4.
verify_report.py: 285 checks, 0 mismatched.

Co-Authored-By: Claude Opus 5.5 <noreply@anthropic.com>
</commit_message>
<xml_diff>
--- a/P25301051-p3-presentation-15-slides.pptx
+++ b/P25301051-p3-presentation-15-slides.pptx
@@ -6963,7 +6963,7 @@
                 <a:ea typeface="Calibri" pitchFamily="34" charset="-122"/>
                 <a:cs typeface="Calibri" pitchFamily="34" charset="-120"/>
               </a:rPr>
-              <a:t>Runs on your own computer; nothing is saved or sent.</a:t>
+              <a:t>Run on your own computer, nothing is saved or sent.</a:t>
             </a:r>
             <a:endParaRPr lang="en-US" sz="1550" dirty="0"/>
           </a:p>
@@ -7392,7 +7392,7 @@
                 <a:ea typeface="Calibri" pitchFamily="34" charset="-122"/>
                 <a:cs typeface="Calibri" pitchFamily="34" charset="-120"/>
               </a:rPr>
-              <a:t>every clause marked in its risk colour, plus a checklist of missing protections</a:t>
+              <a:t>every clause marked in its risk color, plus a checklist of missing protections</a:t>
             </a:r>
             <a:endParaRPr lang="en-US" sz="1450" dirty="0"/>
           </a:p>
@@ -9258,7 +9258,7 @@
                 <a:ea typeface="Calibri" pitchFamily="34" charset="-122"/>
                 <a:cs typeface="Calibri" pitchFamily="34" charset="-120"/>
               </a:rPr>
-              <a:t>Existing tools only find text</a:t>
+              <a:t>CUAD-based tools only find text</a:t>
             </a:r>
             <a:endParaRPr lang="en-US" sz="1650" dirty="0"/>
           </a:p>

</xml_diff>